<commit_message>
A pergunta do slide 3 não era quem usa, era o que precisava saber
"Quem consegue usar" repetia "quem escreve SQL" em três linhas e escondia a
progressão real da imersão: a noite 2 pede Python e PySpark, a 3 pede ML e
SQL, e a de hoje não pede nada. É a coluna que faz a tabela virar argumento.

A noite 4 entra na tabela como a última linha, em destaque — antes ela só
aparecia no rodapé.

Corrigido nos três lugares que repetem a tabela: o slide 3, o README da aula e
o roteiro da noite.

Co-Authored-By: Claude Opus 5 (1M context) <noreply@anthropic.com>
Claude-Session: https://claude.ai/code/session_014F8Ah9ESNzkUAuLUs8E7ES
</commit_message>
<xml_diff>
--- a/aulas/aula-04-app-e-genie/slides/aula-04-app-e-genie.pptx
+++ b/aulas/aula-04-app-e-genie/slides/aula-04-app-e-genie.pptx
@@ -16157,7 +16157,7 @@
                 </a:solidFill>
                 <a:latin typeface="Arial"/>
               </a:rPr>
-              <a:t>Quem, hoje, consegue usar isso?</a:t>
+              <a:t>O que era preciso saber para usar</a:t>
             </a:r>
           </a:p>
         </p:txBody>
@@ -16274,7 +16274,7 @@
                 </a:solidFill>
                 <a:latin typeface="Arial"/>
               </a:rPr>
-              <a:t>QUEM CONSEGUE USAR</a:t>
+              <a:t>O QUE ERA PRECISO SABER</a:t>
             </a:r>
           </a:p>
         </p:txBody>
@@ -16400,7 +16400,7 @@
                 </a:solidFill>
                 <a:latin typeface="Arial"/>
               </a:rPr>
-              <a:t>Quem escreve SQL</a:t>
+              <a:t>SQL</a:t>
             </a:r>
           </a:p>
         </p:txBody>
@@ -16487,7 +16487,7 @@
                 </a:solidFill>
                 <a:latin typeface="Arial"/>
               </a:rPr>
-              <a:t>Noite 2 · o pipeline que roda sozinho</a:t>
+              <a:t>Noite 2 · o pipeline, o dashboard e o Genie</a:t>
             </a:r>
           </a:p>
         </p:txBody>
@@ -16526,7 +16526,7 @@
                 </a:solidFill>
                 <a:latin typeface="Arial"/>
               </a:rPr>
-              <a:t>Quem escreve SQL</a:t>
+              <a:t>Python e PySpark</a:t>
             </a:r>
           </a:p>
         </p:txBody>
@@ -16540,132 +16540,6 @@
         <p:spPr>
           <a:xfrm>
             <a:off x="685800" y="3465576"/>
-            <a:ext cx="10820095" cy="658368"/>
-          </a:xfrm>
-          <a:prstGeom prst="roundRect">
-            <a:avLst>
-              <a:gd name="adj" fmla="val 8000"/>
-            </a:avLst>
-          </a:prstGeom>
-          <a:solidFill>
-            <a:srgbClr val="0D1522"/>
-          </a:solidFill>
-          <a:ln w="15875">
-            <a:solidFill>
-              <a:srgbClr val="1F3A5A"/>
-            </a:solidFill>
-          </a:ln>
-          <a:effectLst/>
-        </p:spPr>
-        <p:style>
-          <a:lnRef idx="1">
-            <a:schemeClr val="accent1"/>
-          </a:lnRef>
-          <a:fillRef idx="3">
-            <a:schemeClr val="accent1"/>
-          </a:fillRef>
-          <a:effectRef idx="2">
-            <a:schemeClr val="accent1"/>
-          </a:effectRef>
-          <a:fontRef idx="minor">
-            <a:schemeClr val="lt1"/>
-          </a:fontRef>
-        </p:style>
-        <p:txBody>
-          <a:bodyPr rtlCol="0" anchor="ctr"/>
-          <a:lstStyle/>
-          <a:p>
-            <a:pPr algn="ctr"/>
-          </a:p>
-        </p:txBody>
-      </p:sp>
-      <p:sp>
-        <p:nvSpPr>
-          <p:cNvPr id="14" name="TextBox 13"/>
-          <p:cNvSpPr txBox="1"/>
-          <p:nvPr/>
-        </p:nvSpPr>
-        <p:spPr>
-          <a:xfrm>
-            <a:off x="996696" y="3683317"/>
-            <a:ext cx="4937759" cy="658368"/>
-          </a:xfrm>
-          <a:prstGeom prst="rect">
-            <a:avLst/>
-          </a:prstGeom>
-          <a:noFill/>
-        </p:spPr>
-        <p:txBody>
-          <a:bodyPr wrap="square" lIns="0" rIns="0" tIns="0" bIns="0" anchor="t">
-            <a:spAutoFit/>
-          </a:bodyPr>
-          <a:lstStyle/>
-          <a:p>
-            <a:pPr algn="l">
-              <a:lnSpc>
-                <a:spcPct val="100000"/>
-              </a:lnSpc>
-            </a:pPr>
-            <a:r>
-              <a:rPr sz="1350" b="1">
-                <a:solidFill>
-                  <a:srgbClr val="FFFFFF"/>
-                </a:solidFill>
-                <a:latin typeface="Arial"/>
-              </a:rPr>
-              <a:t>Noite 2 · o dashboard e o Genie</a:t>
-            </a:r>
-          </a:p>
-        </p:txBody>
-      </p:sp>
-      <p:sp>
-        <p:nvSpPr>
-          <p:cNvPr id="15" name="TextBox 14"/>
-          <p:cNvSpPr txBox="1"/>
-          <p:nvPr/>
-        </p:nvSpPr>
-        <p:spPr>
-          <a:xfrm>
-            <a:off x="6117336" y="3683317"/>
-            <a:ext cx="5059375" cy="658368"/>
-          </a:xfrm>
-          <a:prstGeom prst="rect">
-            <a:avLst/>
-          </a:prstGeom>
-          <a:noFill/>
-        </p:spPr>
-        <p:txBody>
-          <a:bodyPr wrap="square" lIns="0" rIns="0" tIns="0" bIns="0" anchor="t">
-            <a:spAutoFit/>
-          </a:bodyPr>
-          <a:lstStyle/>
-          <a:p>
-            <a:pPr algn="l">
-              <a:lnSpc>
-                <a:spcPct val="100000"/>
-              </a:lnSpc>
-            </a:pPr>
-            <a:r>
-              <a:rPr sz="1350" b="0">
-                <a:solidFill>
-                  <a:srgbClr val="9BAAC0"/>
-                </a:solidFill>
-                <a:latin typeface="Arial"/>
-              </a:rPr>
-              <a:t>Quem abre o dashboard — e é a única porta aberta</a:t>
-            </a:r>
-          </a:p>
-        </p:txBody>
-      </p:sp>
-      <p:sp>
-        <p:nvSpPr>
-          <p:cNvPr id="16" name="Rounded Rectangle 15"/>
-          <p:cNvSpPr/>
-          <p:nvPr/>
-        </p:nvSpPr>
-        <p:spPr>
-          <a:xfrm>
-            <a:off x="685800" y="4251960"/>
             <a:ext cx="10820095" cy="658368"/>
           </a:xfrm>
           <a:prstGeom prst="roundRect">
@@ -16707,6 +16581,132 @@
       </p:sp>
       <p:sp>
         <p:nvSpPr>
+          <p:cNvPr id="14" name="TextBox 13"/>
+          <p:cNvSpPr txBox="1"/>
+          <p:nvPr/>
+        </p:nvSpPr>
+        <p:spPr>
+          <a:xfrm>
+            <a:off x="996696" y="3683317"/>
+            <a:ext cx="4937759" cy="658368"/>
+          </a:xfrm>
+          <a:prstGeom prst="rect">
+            <a:avLst/>
+          </a:prstGeom>
+          <a:noFill/>
+        </p:spPr>
+        <p:txBody>
+          <a:bodyPr wrap="square" lIns="0" rIns="0" tIns="0" bIns="0" anchor="t">
+            <a:spAutoFit/>
+          </a:bodyPr>
+          <a:lstStyle/>
+          <a:p>
+            <a:pPr algn="l">
+              <a:lnSpc>
+                <a:spcPct val="100000"/>
+              </a:lnSpc>
+            </a:pPr>
+            <a:r>
+              <a:rPr sz="1350" b="1">
+                <a:solidFill>
+                  <a:srgbClr val="FF6B5A"/>
+                </a:solidFill>
+                <a:latin typeface="Arial"/>
+              </a:rPr>
+              <a:t>Noite 3 · o modelo e a fila dos 200</a:t>
+            </a:r>
+          </a:p>
+        </p:txBody>
+      </p:sp>
+      <p:sp>
+        <p:nvSpPr>
+          <p:cNvPr id="15" name="TextBox 14"/>
+          <p:cNvSpPr txBox="1"/>
+          <p:nvPr/>
+        </p:nvSpPr>
+        <p:spPr>
+          <a:xfrm>
+            <a:off x="6117336" y="3683317"/>
+            <a:ext cx="5059375" cy="658368"/>
+          </a:xfrm>
+          <a:prstGeom prst="rect">
+            <a:avLst/>
+          </a:prstGeom>
+          <a:noFill/>
+        </p:spPr>
+        <p:txBody>
+          <a:bodyPr wrap="square" lIns="0" rIns="0" tIns="0" bIns="0" anchor="t">
+            <a:spAutoFit/>
+          </a:bodyPr>
+          <a:lstStyle/>
+          <a:p>
+            <a:pPr algn="l">
+              <a:lnSpc>
+                <a:spcPct val="100000"/>
+              </a:lnSpc>
+            </a:pPr>
+            <a:r>
+              <a:rPr sz="1350" b="0">
+                <a:solidFill>
+                  <a:srgbClr val="9BAAC0"/>
+                </a:solidFill>
+                <a:latin typeface="Arial"/>
+              </a:rPr>
+              <a:t>ML e SQL</a:t>
+            </a:r>
+          </a:p>
+        </p:txBody>
+      </p:sp>
+      <p:sp>
+        <p:nvSpPr>
+          <p:cNvPr id="16" name="Rounded Rectangle 15"/>
+          <p:cNvSpPr/>
+          <p:nvPr/>
+        </p:nvSpPr>
+        <p:spPr>
+          <a:xfrm>
+            <a:off x="685800" y="4251960"/>
+            <a:ext cx="10820095" cy="658368"/>
+          </a:xfrm>
+          <a:prstGeom prst="roundRect">
+            <a:avLst>
+              <a:gd name="adj" fmla="val 8000"/>
+            </a:avLst>
+          </a:prstGeom>
+          <a:solidFill>
+            <a:srgbClr val="142337"/>
+          </a:solidFill>
+          <a:ln w="19050">
+            <a:solidFill>
+              <a:srgbClr val="3B9DF5"/>
+            </a:solidFill>
+          </a:ln>
+          <a:effectLst/>
+        </p:spPr>
+        <p:style>
+          <a:lnRef idx="1">
+            <a:schemeClr val="accent1"/>
+          </a:lnRef>
+          <a:fillRef idx="3">
+            <a:schemeClr val="accent1"/>
+          </a:fillRef>
+          <a:effectRef idx="2">
+            <a:schemeClr val="accent1"/>
+          </a:effectRef>
+          <a:fontRef idx="minor">
+            <a:schemeClr val="lt1"/>
+          </a:fontRef>
+        </p:style>
+        <p:txBody>
+          <a:bodyPr rtlCol="0" anchor="ctr"/>
+          <a:lstStyle/>
+          <a:p>
+            <a:pPr algn="ctr"/>
+          </a:p>
+        </p:txBody>
+      </p:sp>
+      <p:sp>
+        <p:nvSpPr>
           <p:cNvPr id="17" name="TextBox 16"/>
           <p:cNvSpPr txBox="1"/>
           <p:nvPr/>
@@ -16735,11 +16735,11 @@
             <a:r>
               <a:rPr sz="1350" b="1">
                 <a:solidFill>
-                  <a:srgbClr val="FF6B5A"/>
-                </a:solidFill>
-                <a:latin typeface="Arial"/>
-              </a:rPr>
-              <a:t>Noite 3 · o modelo e a fila dos 200</a:t>
+                  <a:srgbClr val="3B9DF5"/>
+                </a:solidFill>
+                <a:latin typeface="Arial"/>
+              </a:rPr>
+              <a:t>Noite 4 · o app e o Genie da direção</a:t>
             </a:r>
           </a:p>
         </p:txBody>
@@ -16778,7 +16778,7 @@
                 </a:solidFill>
                 <a:latin typeface="Arial"/>
               </a:rPr>
-              <a:t>Quem escreve SQL</a:t>
+              <a:t>nada — e é a aula de hoje</a:t>
             </a:r>
           </a:p>
         </p:txBody>

</xml_diff>